<commit_message>
Adding a range of unit testing
</commit_message>
<xml_diff>
--- a/report/sustainability_figures/susaf_diagram.pptx
+++ b/report/sustainability_figures/susaf_diagram.pptx
@@ -104,6 +104,11 @@
       </a:defRPr>
     </a:lvl9pPr>
   </p:defaultTextStyle>
+  <p:extLst>
+    <p:ext uri="{EFAFB233-063F-42B5-8137-9DF3F51BA10A}">
+      <p15:sldGuideLst xmlns:p15="http://schemas.microsoft.com/office/powerpoint/2012/main"/>
+    </p:ext>
+  </p:extLst>
 </p:presentation>
 </file>
 
@@ -256,7 +261,7 @@
           <a:p>
             <a:fld id="{C189DA18-C432-C14E-B600-70D8C71D64DC}" type="datetimeFigureOut">
               <a:rPr lang="en-US" smtClean="0"/>
-              <a:t>5/7/25</a:t>
+              <a:t>5/10/25</a:t>
             </a:fld>
             <a:endParaRPr lang="en-US"/>
           </a:p>
@@ -456,7 +461,7 @@
           <a:p>
             <a:fld id="{C189DA18-C432-C14E-B600-70D8C71D64DC}" type="datetimeFigureOut">
               <a:rPr lang="en-US" smtClean="0"/>
-              <a:t>5/7/25</a:t>
+              <a:t>5/10/25</a:t>
             </a:fld>
             <a:endParaRPr lang="en-US"/>
           </a:p>
@@ -666,7 +671,7 @@
           <a:p>
             <a:fld id="{C189DA18-C432-C14E-B600-70D8C71D64DC}" type="datetimeFigureOut">
               <a:rPr lang="en-US" smtClean="0"/>
-              <a:t>5/7/25</a:t>
+              <a:t>5/10/25</a:t>
             </a:fld>
             <a:endParaRPr lang="en-US"/>
           </a:p>
@@ -866,7 +871,7 @@
           <a:p>
             <a:fld id="{C189DA18-C432-C14E-B600-70D8C71D64DC}" type="datetimeFigureOut">
               <a:rPr lang="en-US" smtClean="0"/>
-              <a:t>5/7/25</a:t>
+              <a:t>5/10/25</a:t>
             </a:fld>
             <a:endParaRPr lang="en-US"/>
           </a:p>
@@ -1142,7 +1147,7 @@
           <a:p>
             <a:fld id="{C189DA18-C432-C14E-B600-70D8C71D64DC}" type="datetimeFigureOut">
               <a:rPr lang="en-US" smtClean="0"/>
-              <a:t>5/7/25</a:t>
+              <a:t>5/10/25</a:t>
             </a:fld>
             <a:endParaRPr lang="en-US"/>
           </a:p>
@@ -1410,7 +1415,7 @@
           <a:p>
             <a:fld id="{C189DA18-C432-C14E-B600-70D8C71D64DC}" type="datetimeFigureOut">
               <a:rPr lang="en-US" smtClean="0"/>
-              <a:t>5/7/25</a:t>
+              <a:t>5/10/25</a:t>
             </a:fld>
             <a:endParaRPr lang="en-US"/>
           </a:p>
@@ -1825,7 +1830,7 @@
           <a:p>
             <a:fld id="{C189DA18-C432-C14E-B600-70D8C71D64DC}" type="datetimeFigureOut">
               <a:rPr lang="en-US" smtClean="0"/>
-              <a:t>5/7/25</a:t>
+              <a:t>5/10/25</a:t>
             </a:fld>
             <a:endParaRPr lang="en-US"/>
           </a:p>
@@ -1967,7 +1972,7 @@
           <a:p>
             <a:fld id="{C189DA18-C432-C14E-B600-70D8C71D64DC}" type="datetimeFigureOut">
               <a:rPr lang="en-US" smtClean="0"/>
-              <a:t>5/7/25</a:t>
+              <a:t>5/10/25</a:t>
             </a:fld>
             <a:endParaRPr lang="en-US"/>
           </a:p>
@@ -2080,7 +2085,7 @@
           <a:p>
             <a:fld id="{C189DA18-C432-C14E-B600-70D8C71D64DC}" type="datetimeFigureOut">
               <a:rPr lang="en-US" smtClean="0"/>
-              <a:t>5/7/25</a:t>
+              <a:t>5/10/25</a:t>
             </a:fld>
             <a:endParaRPr lang="en-US"/>
           </a:p>
@@ -2393,7 +2398,7 @@
           <a:p>
             <a:fld id="{C189DA18-C432-C14E-B600-70D8C71D64DC}" type="datetimeFigureOut">
               <a:rPr lang="en-US" smtClean="0"/>
-              <a:t>5/7/25</a:t>
+              <a:t>5/10/25</a:t>
             </a:fld>
             <a:endParaRPr lang="en-US"/>
           </a:p>
@@ -2682,7 +2687,7 @@
           <a:p>
             <a:fld id="{C189DA18-C432-C14E-B600-70D8C71D64DC}" type="datetimeFigureOut">
               <a:rPr lang="en-US" smtClean="0"/>
-              <a:t>5/7/25</a:t>
+              <a:t>5/10/25</a:t>
             </a:fld>
             <a:endParaRPr lang="en-US"/>
           </a:p>
@@ -2925,7 +2930,7 @@
           <a:p>
             <a:fld id="{C189DA18-C432-C14E-B600-70D8C71D64DC}" type="datetimeFigureOut">
               <a:rPr lang="en-US" smtClean="0"/>
-              <a:t>5/7/25</a:t>
+              <a:t>5/10/25</a:t>
             </a:fld>
             <a:endParaRPr lang="en-US"/>
           </a:p>
@@ -3356,7 +3361,7 @@
         </p:nvSpPr>
         <p:spPr>
           <a:xfrm>
-            <a:off x="1684625" y="108548"/>
+            <a:off x="1192666" y="72467"/>
             <a:ext cx="6606760" cy="6292151"/>
           </a:xfrm>
           <a:prstGeom prst="pentagon">
@@ -3369,12 +3374,7 @@
             </a:schemeClr>
           </a:solidFill>
           <a:ln>
-            <a:solidFill>
-              <a:schemeClr val="tx2">
-                <a:lumMod val="75000"/>
-                <a:lumOff val="25000"/>
-              </a:schemeClr>
-            </a:solidFill>
+            <a:noFill/>
           </a:ln>
         </p:spPr>
         <p:style>
@@ -3416,7 +3416,7 @@
         </p:nvSpPr>
         <p:spPr>
           <a:xfrm>
-            <a:off x="2515680" y="980729"/>
+            <a:off x="2022369" y="717323"/>
             <a:ext cx="4944646" cy="4709186"/>
           </a:xfrm>
           <a:prstGeom prst="pentagon">
@@ -3429,12 +3429,7 @@
             </a:schemeClr>
           </a:solidFill>
           <a:ln>
-            <a:solidFill>
-              <a:schemeClr val="tx2">
-                <a:lumMod val="75000"/>
-                <a:lumOff val="25000"/>
-              </a:schemeClr>
-            </a:solidFill>
+            <a:noFill/>
           </a:ln>
         </p:spPr>
         <p:style>
@@ -3476,7 +3471,7 @@
         </p:nvSpPr>
         <p:spPr>
           <a:xfrm>
-            <a:off x="3372003" y="1888503"/>
+            <a:off x="2878692" y="1625097"/>
             <a:ext cx="3231999" cy="3078095"/>
           </a:xfrm>
           <a:prstGeom prst="pentagon">
@@ -3489,12 +3484,7 @@
             </a:schemeClr>
           </a:solidFill>
           <a:ln>
-            <a:solidFill>
-              <a:schemeClr val="tx2">
-                <a:lumMod val="75000"/>
-                <a:lumOff val="25000"/>
-              </a:schemeClr>
-            </a:solidFill>
+            <a:noFill/>
           </a:ln>
         </p:spPr>
         <p:style>
@@ -3539,7 +3529,7 @@
         </p:nvCxnSpPr>
         <p:spPr>
           <a:xfrm flipH="1">
-            <a:off x="4988002" y="108548"/>
+            <a:off x="4496043" y="72467"/>
             <a:ext cx="3" cy="3480023"/>
           </a:xfrm>
           <a:prstGeom prst="line">
@@ -3586,7 +3576,7 @@
         </p:nvCxnSpPr>
         <p:spPr>
           <a:xfrm>
-            <a:off x="1684632" y="2511929"/>
+            <a:off x="1192673" y="2475848"/>
             <a:ext cx="3303364" cy="1076641"/>
           </a:xfrm>
           <a:prstGeom prst="line">
@@ -3625,7 +3615,7 @@
         </p:nvCxnSpPr>
         <p:spPr>
           <a:xfrm flipV="1">
-            <a:off x="2946408" y="3588571"/>
+            <a:off x="2454449" y="3552490"/>
             <a:ext cx="2041587" cy="2812112"/>
           </a:xfrm>
           <a:prstGeom prst="line">
@@ -3664,7 +3654,7 @@
         </p:nvCxnSpPr>
         <p:spPr>
           <a:xfrm flipV="1">
-            <a:off x="4988002" y="2511929"/>
+            <a:off x="4496043" y="2475848"/>
             <a:ext cx="3303376" cy="1076641"/>
           </a:xfrm>
           <a:prstGeom prst="line">
@@ -3703,7 +3693,7 @@
         </p:nvCxnSpPr>
         <p:spPr>
           <a:xfrm>
-            <a:off x="4987995" y="3588571"/>
+            <a:off x="4496036" y="3552490"/>
             <a:ext cx="2041606" cy="2812112"/>
           </a:xfrm>
           <a:prstGeom prst="line">
@@ -3739,7 +3729,7 @@
         </p:nvSpPr>
         <p:spPr>
           <a:xfrm rot="19451426">
-            <a:off x="2032279" y="899527"/>
+            <a:off x="1634517" y="808573"/>
             <a:ext cx="2077508" cy="461665"/>
           </a:xfrm>
           <a:prstGeom prst="rect">
@@ -3757,12 +3747,12 @@
             <a:r>
               <a:rPr lang="en-US" sz="2400" b="1" dirty="0">
                 <a:solidFill>
-                  <a:srgbClr val="0070C0"/>
+                  <a:schemeClr val="accent1"/>
                 </a:solidFill>
                 <a:latin typeface="Arial" panose="020B0604020202020204" pitchFamily="34" charset="0"/>
                 <a:cs typeface="Arial" panose="020B0604020202020204" pitchFamily="34" charset="0"/>
               </a:rPr>
-              <a:t>Social</a:t>
+              <a:t>SOCIAL</a:t>
             </a:r>
           </a:p>
         </p:txBody>
@@ -3781,8 +3771,8 @@
         </p:nvSpPr>
         <p:spPr>
           <a:xfrm rot="2166386">
-            <a:off x="5833429" y="892008"/>
-            <a:ext cx="2077508" cy="461665"/>
+            <a:off x="5110814" y="825093"/>
+            <a:ext cx="2455991" cy="461665"/>
           </a:xfrm>
           <a:prstGeom prst="rect">
             <a:avLst/>
@@ -3799,12 +3789,12 @@
             <a:r>
               <a:rPr lang="en-US" sz="2400" b="1" dirty="0">
                 <a:solidFill>
-                  <a:srgbClr val="0070C0"/>
+                  <a:schemeClr val="accent1"/>
                 </a:solidFill>
                 <a:latin typeface="Arial" panose="020B0604020202020204" pitchFamily="34" charset="0"/>
                 <a:cs typeface="Arial" panose="020B0604020202020204" pitchFamily="34" charset="0"/>
               </a:rPr>
-              <a:t>Independent</a:t>
+              <a:t>INDEPENDENT</a:t>
             </a:r>
           </a:p>
         </p:txBody>
@@ -3823,7 +3813,7 @@
         </p:nvSpPr>
         <p:spPr>
           <a:xfrm rot="17272789">
-            <a:off x="6948842" y="4256714"/>
+            <a:off x="6384595" y="4271673"/>
             <a:ext cx="2077507" cy="461665"/>
           </a:xfrm>
           <a:prstGeom prst="rect">
@@ -3841,12 +3831,12 @@
             <a:r>
               <a:rPr lang="en-US" sz="2400" b="1" dirty="0">
                 <a:solidFill>
-                  <a:srgbClr val="0070C0"/>
+                  <a:schemeClr val="accent1"/>
                 </a:solidFill>
                 <a:latin typeface="Arial" panose="020B0604020202020204" pitchFamily="34" charset="0"/>
                 <a:cs typeface="Arial" panose="020B0604020202020204" pitchFamily="34" charset="0"/>
               </a:rPr>
-              <a:t>Technical</a:t>
+              <a:t>TECHNICAL</a:t>
             </a:r>
           </a:p>
         </p:txBody>
@@ -3865,7 +3855,7 @@
         </p:nvSpPr>
         <p:spPr>
           <a:xfrm rot="4312781">
-            <a:off x="953520" y="4257178"/>
+            <a:off x="520430" y="4308615"/>
             <a:ext cx="2077507" cy="461665"/>
           </a:xfrm>
           <a:prstGeom prst="rect">
@@ -3883,12 +3873,12 @@
             <a:r>
               <a:rPr lang="en-US" sz="2400" b="1" dirty="0">
                 <a:solidFill>
-                  <a:srgbClr val="0070C0"/>
+                  <a:schemeClr val="accent1"/>
                 </a:solidFill>
                 <a:latin typeface="Arial" panose="020B0604020202020204" pitchFamily="34" charset="0"/>
                 <a:cs typeface="Arial" panose="020B0604020202020204" pitchFamily="34" charset="0"/>
               </a:rPr>
-              <a:t>Economic</a:t>
+              <a:t>ECONOMIC</a:t>
             </a:r>
           </a:p>
         </p:txBody>
@@ -3907,8 +3897,8 @@
         </p:nvSpPr>
         <p:spPr>
           <a:xfrm>
-            <a:off x="3827964" y="6414960"/>
-            <a:ext cx="2341166" cy="461665"/>
+            <a:off x="3081988" y="6393543"/>
+            <a:ext cx="2846496" cy="461665"/>
           </a:xfrm>
           <a:prstGeom prst="rect">
             <a:avLst/>
@@ -3925,12 +3915,12 @@
             <a:r>
               <a:rPr lang="en-US" sz="2400" b="1" dirty="0">
                 <a:solidFill>
-                  <a:srgbClr val="0070C0"/>
+                  <a:schemeClr val="accent1"/>
                 </a:solidFill>
                 <a:latin typeface="Arial" panose="020B0604020202020204" pitchFamily="34" charset="0"/>
                 <a:cs typeface="Arial" panose="020B0604020202020204" pitchFamily="34" charset="0"/>
               </a:rPr>
-              <a:t>Environmental</a:t>
+              <a:t>ENVIRONMENTAL</a:t>
             </a:r>
           </a:p>
         </p:txBody>
@@ -3949,14 +3939,14 @@
         </p:nvSpPr>
         <p:spPr>
           <a:xfrm>
-            <a:off x="4887054" y="2262175"/>
+            <a:off x="4393743" y="1998769"/>
             <a:ext cx="731318" cy="731318"/>
           </a:xfrm>
           <a:prstGeom prst="roundRect">
             <a:avLst/>
           </a:prstGeom>
           <a:solidFill>
-            <a:srgbClr val="92D050"/>
+            <a:schemeClr val="accent6"/>
           </a:solidFill>
           <a:ln>
             <a:solidFill>
@@ -4010,7 +4000,7 @@
         </p:nvSpPr>
         <p:spPr>
           <a:xfrm>
-            <a:off x="4787828" y="2320610"/>
+            <a:off x="4294517" y="2057204"/>
             <a:ext cx="933331" cy="646331"/>
           </a:xfrm>
           <a:prstGeom prst="rect">
@@ -4052,14 +4042,14 @@
         </p:nvSpPr>
         <p:spPr>
           <a:xfrm>
-            <a:off x="5618887" y="2403366"/>
+            <a:off x="5125576" y="2139960"/>
             <a:ext cx="731318" cy="731318"/>
           </a:xfrm>
           <a:prstGeom prst="roundRect">
             <a:avLst/>
           </a:prstGeom>
           <a:solidFill>
-            <a:srgbClr val="92D050"/>
+            <a:schemeClr val="accent6"/>
           </a:solidFill>
           <a:ln>
             <a:solidFill>
@@ -4113,7 +4103,7 @@
         </p:nvSpPr>
         <p:spPr>
           <a:xfrm>
-            <a:off x="5525302" y="2397412"/>
+            <a:off x="5041305" y="2121377"/>
             <a:ext cx="922346" cy="784830"/>
           </a:xfrm>
           <a:prstGeom prst="rect">
@@ -4155,14 +4145,14 @@
         </p:nvSpPr>
         <p:spPr>
           <a:xfrm>
-            <a:off x="3104789" y="2227676"/>
+            <a:off x="2611478" y="1964270"/>
             <a:ext cx="731318" cy="731318"/>
           </a:xfrm>
           <a:prstGeom prst="roundRect">
             <a:avLst/>
           </a:prstGeom>
           <a:solidFill>
-            <a:srgbClr val="92D050"/>
+            <a:schemeClr val="accent6"/>
           </a:solidFill>
           <a:ln>
             <a:solidFill>
@@ -4216,7 +4206,7 @@
         </p:nvSpPr>
         <p:spPr>
           <a:xfrm>
-            <a:off x="3015756" y="2275179"/>
+            <a:off x="2522445" y="2011773"/>
             <a:ext cx="922341" cy="646331"/>
           </a:xfrm>
           <a:prstGeom prst="rect">
@@ -4258,14 +4248,14 @@
         </p:nvSpPr>
         <p:spPr>
           <a:xfrm>
-            <a:off x="3703969" y="1699840"/>
+            <a:off x="3210658" y="1436434"/>
             <a:ext cx="731318" cy="731318"/>
           </a:xfrm>
           <a:prstGeom prst="roundRect">
             <a:avLst/>
           </a:prstGeom>
           <a:solidFill>
-            <a:srgbClr val="92D050"/>
+            <a:schemeClr val="accent6"/>
           </a:solidFill>
           <a:ln>
             <a:solidFill>
@@ -4319,7 +4309,7 @@
         </p:nvSpPr>
         <p:spPr>
           <a:xfrm>
-            <a:off x="3614936" y="1747343"/>
+            <a:off x="3121625" y="1483937"/>
             <a:ext cx="922341" cy="646331"/>
           </a:xfrm>
           <a:prstGeom prst="rect">
@@ -4361,14 +4351,14 @@
         </p:nvSpPr>
         <p:spPr>
           <a:xfrm>
-            <a:off x="2330650" y="1751850"/>
+            <a:off x="1837339" y="1488444"/>
             <a:ext cx="731318" cy="731318"/>
           </a:xfrm>
           <a:prstGeom prst="roundRect">
             <a:avLst/>
           </a:prstGeom>
           <a:solidFill>
-            <a:srgbClr val="92D050"/>
+            <a:schemeClr val="accent6"/>
           </a:solidFill>
           <a:ln>
             <a:solidFill>
@@ -4422,7 +4412,7 @@
         </p:nvSpPr>
         <p:spPr>
           <a:xfrm>
-            <a:off x="2246075" y="1872819"/>
+            <a:off x="1752764" y="1609413"/>
             <a:ext cx="922341" cy="507831"/>
           </a:xfrm>
           <a:prstGeom prst="rect">
@@ -4464,14 +4454,14 @@
         </p:nvSpPr>
         <p:spPr>
           <a:xfrm>
-            <a:off x="2232185" y="3817343"/>
+            <a:off x="1738874" y="3553937"/>
             <a:ext cx="731318" cy="731318"/>
           </a:xfrm>
           <a:prstGeom prst="roundRect">
             <a:avLst/>
           </a:prstGeom>
           <a:solidFill>
-            <a:srgbClr val="92D050"/>
+            <a:schemeClr val="accent6"/>
           </a:solidFill>
           <a:ln>
             <a:solidFill>
@@ -4525,7 +4515,7 @@
         </p:nvSpPr>
         <p:spPr>
           <a:xfrm>
-            <a:off x="2158752" y="3853522"/>
+            <a:off x="1665441" y="3590116"/>
             <a:ext cx="868902" cy="646331"/>
           </a:xfrm>
           <a:prstGeom prst="rect">
@@ -4567,7 +4557,7 @@
         </p:nvSpPr>
         <p:spPr>
           <a:xfrm>
-            <a:off x="5595956" y="3749486"/>
+            <a:off x="5102645" y="3486080"/>
             <a:ext cx="731318" cy="731318"/>
           </a:xfrm>
           <a:prstGeom prst="roundRect">
@@ -4578,7 +4568,7 @@
           </a:solidFill>
           <a:ln>
             <a:solidFill>
-              <a:schemeClr val="accent2"/>
+              <a:srgbClr val="FFC819"/>
             </a:solidFill>
           </a:ln>
         </p:spPr>
@@ -4628,7 +4618,7 @@
         </p:nvSpPr>
         <p:spPr>
           <a:xfrm>
-            <a:off x="5509676" y="3872455"/>
+            <a:off x="5016365" y="3645145"/>
             <a:ext cx="922341" cy="507831"/>
           </a:xfrm>
           <a:prstGeom prst="rect">
@@ -4670,7 +4660,7 @@
         </p:nvSpPr>
         <p:spPr>
           <a:xfrm>
-            <a:off x="5604834" y="1615998"/>
+            <a:off x="5111523" y="1352592"/>
             <a:ext cx="731318" cy="731318"/>
           </a:xfrm>
           <a:prstGeom prst="roundRect">
@@ -4681,7 +4671,7 @@
           </a:solidFill>
           <a:ln>
             <a:solidFill>
-              <a:schemeClr val="accent2"/>
+              <a:srgbClr val="FFC819"/>
             </a:solidFill>
           </a:ln>
         </p:spPr>
@@ -4731,7 +4721,7 @@
         </p:nvSpPr>
         <p:spPr>
           <a:xfrm>
-            <a:off x="5518554" y="1603040"/>
+            <a:off x="5013477" y="1342395"/>
             <a:ext cx="922341" cy="784830"/>
           </a:xfrm>
           <a:prstGeom prst="rect">
@@ -4773,7 +4763,7 @@
         </p:nvSpPr>
         <p:spPr>
           <a:xfrm>
-            <a:off x="4300921" y="1099971"/>
+            <a:off x="3807610" y="836565"/>
             <a:ext cx="731318" cy="731318"/>
           </a:xfrm>
           <a:prstGeom prst="roundRect">
@@ -4784,7 +4774,7 @@
           </a:solidFill>
           <a:ln>
             <a:solidFill>
-              <a:schemeClr val="accent2"/>
+              <a:srgbClr val="FFC819"/>
             </a:solidFill>
           </a:ln>
         </p:spPr>
@@ -4834,7 +4824,7 @@
         </p:nvSpPr>
         <p:spPr>
           <a:xfrm>
-            <a:off x="4202284" y="1198226"/>
+            <a:off x="3708973" y="934820"/>
             <a:ext cx="922341" cy="507831"/>
           </a:xfrm>
           <a:prstGeom prst="rect">
@@ -4876,7 +4866,7 @@
         </p:nvSpPr>
         <p:spPr>
           <a:xfrm>
-            <a:off x="1935067" y="2958994"/>
+            <a:off x="1441756" y="2695588"/>
             <a:ext cx="731318" cy="731318"/>
           </a:xfrm>
           <a:prstGeom prst="roundRect">
@@ -4887,7 +4877,7 @@
           </a:solidFill>
           <a:ln>
             <a:solidFill>
-              <a:schemeClr val="accent2"/>
+              <a:srgbClr val="FFC819"/>
             </a:solidFill>
           </a:ln>
         </p:spPr>
@@ -4937,7 +4927,7 @@
         </p:nvSpPr>
         <p:spPr>
           <a:xfrm>
-            <a:off x="1840395" y="2934057"/>
+            <a:off x="1357561" y="2650116"/>
             <a:ext cx="922341" cy="784830"/>
           </a:xfrm>
           <a:prstGeom prst="rect">
@@ -4982,7 +4972,7 @@
         </p:nvCxnSpPr>
         <p:spPr>
           <a:xfrm rot="5400000">
-            <a:off x="2919064" y="1578611"/>
+            <a:off x="2425753" y="1315205"/>
             <a:ext cx="1494838" cy="2000195"/>
           </a:xfrm>
           <a:prstGeom prst="curvedConnector2">
@@ -4990,7 +4980,7 @@
           </a:prstGeom>
           <a:ln w="38100">
             <a:solidFill>
-              <a:srgbClr val="F77836"/>
+              <a:srgbClr val="FFC819"/>
             </a:solidFill>
             <a:tailEnd type="triangle"/>
           </a:ln>
@@ -5027,7 +5017,7 @@
         </p:nvCxnSpPr>
         <p:spPr>
           <a:xfrm rot="16200000" flipV="1">
-            <a:off x="5403400" y="1048905"/>
+            <a:off x="4910089" y="785499"/>
             <a:ext cx="162241" cy="971946"/>
           </a:xfrm>
           <a:prstGeom prst="curvedConnector2">
@@ -5035,7 +5025,7 @@
           </a:prstGeom>
           <a:ln w="38100">
             <a:solidFill>
-              <a:srgbClr val="F77836"/>
+              <a:srgbClr val="FFC819"/>
             </a:solidFill>
             <a:tailEnd type="triangle"/>
           </a:ln>
@@ -5072,7 +5062,7 @@
         </p:nvCxnSpPr>
         <p:spPr>
           <a:xfrm rot="16200000" flipV="1">
-            <a:off x="4724937" y="1734398"/>
+            <a:off x="4231626" y="1470992"/>
             <a:ext cx="219565" cy="835989"/>
           </a:xfrm>
           <a:prstGeom prst="curvedConnector2">
@@ -5118,7 +5108,7 @@
         </p:nvCxnSpPr>
         <p:spPr>
           <a:xfrm rot="16200000" flipV="1">
-            <a:off x="3211125" y="1968353"/>
+            <a:off x="2717814" y="1704947"/>
             <a:ext cx="110167" cy="408480"/>
           </a:xfrm>
           <a:prstGeom prst="curvedConnector2">
@@ -5163,7 +5153,7 @@
         </p:nvCxnSpPr>
         <p:spPr>
           <a:xfrm rot="16200000" flipH="1">
-            <a:off x="1988690" y="3208189"/>
+            <a:off x="1495379" y="2944783"/>
             <a:ext cx="1693376" cy="256250"/>
           </a:xfrm>
           <a:prstGeom prst="curvedConnector4">
@@ -5208,17 +5198,14 @@
         </p:nvSpPr>
         <p:spPr>
           <a:xfrm>
-            <a:off x="4208921" y="4279600"/>
+            <a:off x="3715610" y="4016194"/>
             <a:ext cx="731318" cy="731318"/>
           </a:xfrm>
           <a:prstGeom prst="roundRect">
             <a:avLst/>
           </a:prstGeom>
           <a:solidFill>
-            <a:schemeClr val="accent5">
-              <a:lumMod val="40000"/>
-              <a:lumOff val="60000"/>
-            </a:schemeClr>
+            <a:schemeClr val="accent5"/>
           </a:solidFill>
           <a:ln>
             <a:solidFill>
@@ -5272,7 +5259,7 @@
         </p:nvSpPr>
         <p:spPr>
           <a:xfrm>
-            <a:off x="4113409" y="4323546"/>
+            <a:off x="3620098" y="4060140"/>
             <a:ext cx="922341" cy="646331"/>
           </a:xfrm>
           <a:prstGeom prst="rect">
@@ -5334,17 +5321,14 @@
         </p:nvSpPr>
         <p:spPr>
           <a:xfrm>
-            <a:off x="4940897" y="4281053"/>
+            <a:off x="4447586" y="4017647"/>
             <a:ext cx="731318" cy="731318"/>
           </a:xfrm>
           <a:prstGeom prst="roundRect">
             <a:avLst/>
           </a:prstGeom>
           <a:solidFill>
-            <a:schemeClr val="accent5">
-              <a:lumMod val="40000"/>
-              <a:lumOff val="60000"/>
-            </a:schemeClr>
+            <a:schemeClr val="accent5"/>
           </a:solidFill>
           <a:ln>
             <a:solidFill>
@@ -5398,7 +5382,7 @@
         </p:nvSpPr>
         <p:spPr>
           <a:xfrm>
-            <a:off x="4857742" y="4250857"/>
+            <a:off x="4364746" y="4001524"/>
             <a:ext cx="922341" cy="784830"/>
           </a:xfrm>
           <a:prstGeom prst="rect">
@@ -5444,7 +5428,7 @@
         </p:nvCxnSpPr>
         <p:spPr>
           <a:xfrm rot="5400000">
-            <a:off x="4282498" y="2459319"/>
+            <a:off x="3789187" y="2195913"/>
             <a:ext cx="2208105" cy="4067672"/>
           </a:xfrm>
           <a:prstGeom prst="curvedConnector2">
@@ -5486,17 +5470,14 @@
         </p:nvSpPr>
         <p:spPr>
           <a:xfrm>
-            <a:off x="6281622" y="4262707"/>
+            <a:off x="5788311" y="3999301"/>
             <a:ext cx="731318" cy="731318"/>
           </a:xfrm>
           <a:prstGeom prst="roundRect">
             <a:avLst/>
           </a:prstGeom>
           <a:solidFill>
-            <a:schemeClr val="accent5">
-              <a:lumMod val="40000"/>
-              <a:lumOff val="60000"/>
-            </a:schemeClr>
+            <a:schemeClr val="accent5"/>
           </a:solidFill>
           <a:ln>
             <a:solidFill>
@@ -5550,7 +5531,7 @@
         </p:nvSpPr>
         <p:spPr>
           <a:xfrm>
-            <a:off x="6198467" y="4339202"/>
+            <a:off x="5705156" y="4075796"/>
             <a:ext cx="922341" cy="646331"/>
           </a:xfrm>
           <a:prstGeom prst="rect">
@@ -5592,17 +5573,14 @@
         </p:nvSpPr>
         <p:spPr>
           <a:xfrm>
-            <a:off x="6674460" y="3680116"/>
+            <a:off x="6181149" y="3416710"/>
             <a:ext cx="731318" cy="731318"/>
           </a:xfrm>
           <a:prstGeom prst="roundRect">
             <a:avLst/>
           </a:prstGeom>
           <a:solidFill>
-            <a:schemeClr val="accent5">
-              <a:lumMod val="40000"/>
-              <a:lumOff val="60000"/>
-            </a:schemeClr>
+            <a:schemeClr val="accent5"/>
           </a:solidFill>
           <a:ln>
             <a:solidFill>
@@ -5656,7 +5634,7 @@
         </p:nvSpPr>
         <p:spPr>
           <a:xfrm>
-            <a:off x="6599037" y="3736620"/>
+            <a:off x="6105726" y="3473214"/>
             <a:ext cx="922341" cy="646331"/>
           </a:xfrm>
           <a:prstGeom prst="rect">
@@ -5686,63 +5664,6 @@
       </p:sp>
       <p:sp>
         <p:nvSpPr>
-          <p:cNvPr id="1077" name="Oval 1076">
-            <a:extLst>
-              <a:ext uri="{FF2B5EF4-FFF2-40B4-BE49-F238E27FC236}">
-                <a16:creationId xmlns:a16="http://schemas.microsoft.com/office/drawing/2014/main" id="{E8008719-6DEC-6DBC-3CD4-934606292693}"/>
-              </a:ext>
-            </a:extLst>
-          </p:cNvPr>
-          <p:cNvSpPr/>
-          <p:nvPr/>
-        </p:nvSpPr>
-        <p:spPr>
-          <a:xfrm>
-            <a:off x="8056709" y="5252437"/>
-            <a:ext cx="257642" cy="257642"/>
-          </a:xfrm>
-          <a:prstGeom prst="ellipse">
-            <a:avLst/>
-          </a:prstGeom>
-          <a:solidFill>
-            <a:schemeClr val="accent5">
-              <a:lumMod val="40000"/>
-              <a:lumOff val="60000"/>
-            </a:schemeClr>
-          </a:solidFill>
-          <a:ln>
-            <a:solidFill>
-              <a:schemeClr val="accent5"/>
-            </a:solidFill>
-          </a:ln>
-        </p:spPr>
-        <p:style>
-          <a:lnRef idx="2">
-            <a:schemeClr val="accent1">
-              <a:shade val="15000"/>
-            </a:schemeClr>
-          </a:lnRef>
-          <a:fillRef idx="1">
-            <a:schemeClr val="accent1"/>
-          </a:fillRef>
-          <a:effectRef idx="0">
-            <a:schemeClr val="accent1"/>
-          </a:effectRef>
-          <a:fontRef idx="minor">
-            <a:schemeClr val="lt1"/>
-          </a:fontRef>
-        </p:style>
-        <p:txBody>
-          <a:bodyPr rtlCol="0" anchor="ctr"/>
-          <a:lstStyle/>
-          <a:p>
-            <a:pPr algn="ctr"/>
-            <a:endParaRPr lang="en-US"/>
-          </a:p>
-        </p:txBody>
-      </p:sp>
-      <p:sp>
-        <p:nvSpPr>
           <p:cNvPr id="1078" name="TextBox 1077">
             <a:extLst>
               <a:ext uri="{FF2B5EF4-FFF2-40B4-BE49-F238E27FC236}">
@@ -5755,8 +5676,8 @@
         </p:nvSpPr>
         <p:spPr>
           <a:xfrm>
-            <a:off x="8397098" y="5233080"/>
-            <a:ext cx="2369327" cy="276999"/>
+            <a:off x="7903787" y="4969674"/>
+            <a:ext cx="2780239" cy="276999"/>
           </a:xfrm>
           <a:prstGeom prst="rect">
             <a:avLst/>
@@ -5771,62 +5692,8 @@
           <a:p>
             <a:r>
               <a:rPr lang="en-US" sz="1200" dirty="0"/>
-              <a:t>Green and scalable development</a:t>
-            </a:r>
-          </a:p>
-        </p:txBody>
-      </p:sp>
-      <p:sp>
-        <p:nvSpPr>
-          <p:cNvPr id="1079" name="Oval 1078">
-            <a:extLst>
-              <a:ext uri="{FF2B5EF4-FFF2-40B4-BE49-F238E27FC236}">
-                <a16:creationId xmlns:a16="http://schemas.microsoft.com/office/drawing/2014/main" id="{F9F7627F-6A88-C31F-1612-56BBFD4818CA}"/>
-              </a:ext>
-            </a:extLst>
-          </p:cNvPr>
-          <p:cNvSpPr/>
-          <p:nvPr/>
-        </p:nvSpPr>
-        <p:spPr>
-          <a:xfrm>
-            <a:off x="8056709" y="5648773"/>
-            <a:ext cx="257642" cy="257642"/>
-          </a:xfrm>
-          <a:prstGeom prst="ellipse">
-            <a:avLst/>
-          </a:prstGeom>
-          <a:solidFill>
-            <a:srgbClr val="FFC000"/>
-          </a:solidFill>
-          <a:ln>
-            <a:solidFill>
-              <a:schemeClr val="accent2"/>
-            </a:solidFill>
-          </a:ln>
-        </p:spPr>
-        <p:style>
-          <a:lnRef idx="2">
-            <a:schemeClr val="accent1">
-              <a:shade val="15000"/>
-            </a:schemeClr>
-          </a:lnRef>
-          <a:fillRef idx="1">
-            <a:schemeClr val="accent1"/>
-          </a:fillRef>
-          <a:effectRef idx="0">
-            <a:schemeClr val="accent1"/>
-          </a:effectRef>
-          <a:fontRef idx="minor">
-            <a:schemeClr val="lt1"/>
-          </a:fontRef>
-        </p:style>
-        <p:txBody>
-          <a:bodyPr rtlCol="0" anchor="ctr"/>
-          <a:lstStyle/>
-          <a:p>
-            <a:pPr algn="ctr"/>
-            <a:endParaRPr lang="en-US"/>
+              <a:t>GREEN AND SCALABE DEVELOPMENT</a:t>
+            </a:r>
           </a:p>
         </p:txBody>
       </p:sp>
@@ -5844,8 +5711,8 @@
         </p:nvSpPr>
         <p:spPr>
           <a:xfrm>
-            <a:off x="8397098" y="5629416"/>
-            <a:ext cx="2369327" cy="276999"/>
+            <a:off x="7903787" y="5366010"/>
+            <a:ext cx="2691610" cy="276999"/>
           </a:xfrm>
           <a:prstGeom prst="rect">
             <a:avLst/>
@@ -5860,62 +5727,8 @@
           <a:p>
             <a:r>
               <a:rPr lang="en-US" sz="1200" dirty="0"/>
-              <a:t>Inclusive and accessible design</a:t>
-            </a:r>
-          </a:p>
-        </p:txBody>
-      </p:sp>
-      <p:sp>
-        <p:nvSpPr>
-          <p:cNvPr id="1081" name="Oval 1080">
-            <a:extLst>
-              <a:ext uri="{FF2B5EF4-FFF2-40B4-BE49-F238E27FC236}">
-                <a16:creationId xmlns:a16="http://schemas.microsoft.com/office/drawing/2014/main" id="{5FBF41CC-68DE-D35F-CD03-F0E9F548EDC2}"/>
-              </a:ext>
-            </a:extLst>
-          </p:cNvPr>
-          <p:cNvSpPr/>
-          <p:nvPr/>
-        </p:nvSpPr>
-        <p:spPr>
-          <a:xfrm>
-            <a:off x="8051934" y="6059385"/>
-            <a:ext cx="257642" cy="257642"/>
-          </a:xfrm>
-          <a:prstGeom prst="ellipse">
-            <a:avLst/>
-          </a:prstGeom>
-          <a:solidFill>
-            <a:srgbClr val="92D050"/>
-          </a:solidFill>
-          <a:ln>
-            <a:solidFill>
-              <a:schemeClr val="accent6"/>
-            </a:solidFill>
-          </a:ln>
-        </p:spPr>
-        <p:style>
-          <a:lnRef idx="2">
-            <a:schemeClr val="accent1">
-              <a:shade val="15000"/>
-            </a:schemeClr>
-          </a:lnRef>
-          <a:fillRef idx="1">
-            <a:schemeClr val="accent1"/>
-          </a:fillRef>
-          <a:effectRef idx="0">
-            <a:schemeClr val="accent1"/>
-          </a:effectRef>
-          <a:fontRef idx="minor">
-            <a:schemeClr val="lt1"/>
-          </a:fontRef>
-        </p:style>
-        <p:txBody>
-          <a:bodyPr rtlCol="0" anchor="ctr"/>
-          <a:lstStyle/>
-          <a:p>
-            <a:pPr algn="ctr"/>
-            <a:endParaRPr lang="en-US"/>
+              <a:t>INCLUSIVE AND ACCESSIBLE DESIGN</a:t>
+            </a:r>
           </a:p>
         </p:txBody>
       </p:sp>
@@ -5933,8 +5746,8 @@
         </p:nvSpPr>
         <p:spPr>
           <a:xfrm>
-            <a:off x="8392323" y="6040028"/>
-            <a:ext cx="2369327" cy="276999"/>
+            <a:off x="7899012" y="5776622"/>
+            <a:ext cx="2580172" cy="276999"/>
           </a:xfrm>
           <a:prstGeom prst="rect">
             <a:avLst/>
@@ -5949,7 +5762,7 @@
           <a:p>
             <a:r>
               <a:rPr lang="en-US" sz="1200" dirty="0"/>
-              <a:t>Building trust and community</a:t>
+              <a:t>BUILDING TRUST AND COMMUNITY</a:t>
             </a:r>
           </a:p>
         </p:txBody>
@@ -5968,17 +5781,14 @@
         </p:nvSpPr>
         <p:spPr>
           <a:xfrm>
-            <a:off x="5402067" y="5679717"/>
+            <a:off x="4908756" y="5416311"/>
             <a:ext cx="731318" cy="731318"/>
           </a:xfrm>
           <a:prstGeom prst="roundRect">
             <a:avLst/>
           </a:prstGeom>
           <a:solidFill>
-            <a:schemeClr val="accent5">
-              <a:lumMod val="40000"/>
-              <a:lumOff val="60000"/>
-            </a:schemeClr>
+            <a:schemeClr val="accent5"/>
           </a:solidFill>
           <a:ln>
             <a:solidFill>
@@ -6032,7 +5842,7 @@
         </p:nvSpPr>
         <p:spPr>
           <a:xfrm>
-            <a:off x="5310775" y="5660898"/>
+            <a:off x="4819696" y="5385986"/>
             <a:ext cx="922341" cy="784830"/>
           </a:xfrm>
           <a:prstGeom prst="rect">
@@ -6074,17 +5884,14 @@
         </p:nvSpPr>
         <p:spPr>
           <a:xfrm>
-            <a:off x="3970800" y="5675505"/>
+            <a:off x="3477489" y="5412099"/>
             <a:ext cx="731318" cy="731318"/>
           </a:xfrm>
           <a:prstGeom prst="roundRect">
             <a:avLst/>
           </a:prstGeom>
           <a:solidFill>
-            <a:schemeClr val="accent5">
-              <a:lumMod val="40000"/>
-              <a:lumOff val="60000"/>
-            </a:schemeClr>
+            <a:schemeClr val="accent5"/>
           </a:solidFill>
           <a:ln>
             <a:solidFill>
@@ -6138,7 +5945,7 @@
         </p:nvSpPr>
         <p:spPr>
           <a:xfrm>
-            <a:off x="3883180" y="5728903"/>
+            <a:off x="3389869" y="5465497"/>
             <a:ext cx="922341" cy="646331"/>
           </a:xfrm>
           <a:prstGeom prst="rect">
@@ -6192,7 +5999,7 @@
         </p:nvCxnSpPr>
         <p:spPr>
           <a:xfrm>
-            <a:off x="5668870" y="4648165"/>
+            <a:off x="5175559" y="4384759"/>
             <a:ext cx="646047" cy="8263"/>
           </a:xfrm>
           <a:prstGeom prst="curvedConnector3">
@@ -6240,7 +6047,7 @@
         </p:nvCxnSpPr>
         <p:spPr>
           <a:xfrm rot="5400000">
-            <a:off x="5864658" y="5262752"/>
+            <a:off x="5371347" y="4999346"/>
             <a:ext cx="1051351" cy="513896"/>
           </a:xfrm>
           <a:prstGeom prst="curvedConnector2">
@@ -6285,7 +6092,7 @@
         </p:nvCxnSpPr>
         <p:spPr>
           <a:xfrm rot="10800000">
-            <a:off x="4702119" y="6041164"/>
+            <a:off x="4208808" y="5777758"/>
             <a:ext cx="699949" cy="4212"/>
           </a:xfrm>
           <a:prstGeom prst="curvedConnector3">
@@ -6327,7 +6134,7 @@
         </p:nvSpPr>
         <p:spPr>
           <a:xfrm rot="5400000">
-            <a:off x="5113093" y="2204064"/>
+            <a:off x="4619782" y="1940658"/>
             <a:ext cx="2266876" cy="1541335"/>
           </a:xfrm>
           <a:prstGeom prst="arc">
@@ -6338,7 +6145,7 @@
           </a:prstGeom>
           <a:ln w="38100">
             <a:solidFill>
-              <a:srgbClr val="F77836"/>
+              <a:srgbClr val="FFC819"/>
             </a:solidFill>
             <a:headEnd type="triangle" w="med" len="med"/>
             <a:tailEnd type="none" w="med" len="med"/>
@@ -6381,14 +6188,14 @@
         </p:nvSpPr>
         <p:spPr>
           <a:xfrm>
-            <a:off x="7054727" y="2657785"/>
+            <a:off x="6561416" y="2394379"/>
             <a:ext cx="731318" cy="731318"/>
           </a:xfrm>
           <a:prstGeom prst="roundRect">
             <a:avLst/>
           </a:prstGeom>
           <a:solidFill>
-            <a:srgbClr val="FF94A2"/>
+            <a:srgbClr val="FF0017"/>
           </a:solidFill>
           <a:ln>
             <a:solidFill>
@@ -6442,7 +6249,7 @@
         </p:nvSpPr>
         <p:spPr>
           <a:xfrm>
-            <a:off x="6953183" y="2701787"/>
+            <a:off x="6459872" y="2438381"/>
             <a:ext cx="922341" cy="646331"/>
           </a:xfrm>
           <a:prstGeom prst="rect">
@@ -6484,14 +6291,14 @@
         </p:nvSpPr>
         <p:spPr>
           <a:xfrm>
-            <a:off x="2621396" y="5231549"/>
+            <a:off x="2128085" y="4968143"/>
             <a:ext cx="731318" cy="731318"/>
           </a:xfrm>
           <a:prstGeom prst="roundRect">
             <a:avLst/>
           </a:prstGeom>
           <a:solidFill>
-            <a:srgbClr val="FF94A2"/>
+            <a:srgbClr val="FF0017"/>
           </a:solidFill>
           <a:ln>
             <a:solidFill>
@@ -6545,7 +6352,7 @@
         </p:nvSpPr>
         <p:spPr>
           <a:xfrm>
-            <a:off x="2534437" y="5293108"/>
+            <a:off x="2041126" y="5029702"/>
             <a:ext cx="922341" cy="646331"/>
           </a:xfrm>
           <a:prstGeom prst="rect">
@@ -6575,60 +6382,6 @@
       </p:sp>
       <p:sp>
         <p:nvSpPr>
-          <p:cNvPr id="1128" name="Oval 1127">
-            <a:extLst>
-              <a:ext uri="{FF2B5EF4-FFF2-40B4-BE49-F238E27FC236}">
-                <a16:creationId xmlns:a16="http://schemas.microsoft.com/office/drawing/2014/main" id="{8EF64A45-5134-EB9D-AA9C-E6E613AF851F}"/>
-              </a:ext>
-            </a:extLst>
-          </p:cNvPr>
-          <p:cNvSpPr/>
-          <p:nvPr/>
-        </p:nvSpPr>
-        <p:spPr>
-          <a:xfrm>
-            <a:off x="8056709" y="6456979"/>
-            <a:ext cx="257642" cy="257642"/>
-          </a:xfrm>
-          <a:prstGeom prst="ellipse">
-            <a:avLst/>
-          </a:prstGeom>
-          <a:solidFill>
-            <a:srgbClr val="FF94A2"/>
-          </a:solidFill>
-          <a:ln>
-            <a:solidFill>
-              <a:srgbClr val="FF0000"/>
-            </a:solidFill>
-          </a:ln>
-        </p:spPr>
-        <p:style>
-          <a:lnRef idx="2">
-            <a:schemeClr val="accent1">
-              <a:shade val="15000"/>
-            </a:schemeClr>
-          </a:lnRef>
-          <a:fillRef idx="1">
-            <a:schemeClr val="accent1"/>
-          </a:fillRef>
-          <a:effectRef idx="0">
-            <a:schemeClr val="accent1"/>
-          </a:effectRef>
-          <a:fontRef idx="minor">
-            <a:schemeClr val="lt1"/>
-          </a:fontRef>
-        </p:style>
-        <p:txBody>
-          <a:bodyPr rtlCol="0" anchor="ctr"/>
-          <a:lstStyle/>
-          <a:p>
-            <a:pPr algn="ctr"/>
-            <a:endParaRPr lang="en-US"/>
-          </a:p>
-        </p:txBody>
-      </p:sp>
-      <p:sp>
-        <p:nvSpPr>
           <p:cNvPr id="1129" name="TextBox 1128">
             <a:extLst>
               <a:ext uri="{FF2B5EF4-FFF2-40B4-BE49-F238E27FC236}">
@@ -6641,8 +6394,8 @@
         </p:nvSpPr>
         <p:spPr>
           <a:xfrm>
-            <a:off x="8397098" y="6437622"/>
-            <a:ext cx="2570622" cy="276999"/>
+            <a:off x="7903787" y="6174216"/>
+            <a:ext cx="3201344" cy="276999"/>
           </a:xfrm>
           <a:prstGeom prst="rect">
             <a:avLst/>
@@ -6657,7 +6410,7 @@
           <a:p>
             <a:r>
               <a:rPr lang="en-US" sz="1200" dirty="0"/>
-              <a:t>Sustainable technical infrastructure</a:t>
+              <a:t>SUSTAINABLE TECHNICAL INFRASTRUCTURE</a:t>
             </a:r>
           </a:p>
         </p:txBody>
@@ -6679,7 +6432,7 @@
         </p:nvCxnSpPr>
         <p:spPr>
           <a:xfrm rot="5400000" flipH="1" flipV="1">
-            <a:off x="6737531" y="2763556"/>
+            <a:off x="6244220" y="2500150"/>
             <a:ext cx="171016" cy="447274"/>
           </a:xfrm>
           <a:prstGeom prst="curvedConnector2">
@@ -6721,14 +6474,14 @@
         </p:nvSpPr>
         <p:spPr>
           <a:xfrm>
-            <a:off x="6233743" y="3072701"/>
+            <a:off x="5740432" y="2809295"/>
             <a:ext cx="731318" cy="731318"/>
           </a:xfrm>
           <a:prstGeom prst="roundRect">
             <a:avLst/>
           </a:prstGeom>
           <a:solidFill>
-            <a:srgbClr val="FF94A2"/>
+            <a:srgbClr val="FF0017"/>
           </a:solidFill>
           <a:ln>
             <a:solidFill>
@@ -6782,7 +6535,7 @@
         </p:nvSpPr>
         <p:spPr>
           <a:xfrm>
-            <a:off x="6145963" y="3252775"/>
+            <a:off x="5652652" y="2989369"/>
             <a:ext cx="922341" cy="369332"/>
           </a:xfrm>
           <a:prstGeom prst="rect">
@@ -6832,7 +6585,7 @@
         </p:blipFill>
         <p:spPr>
           <a:xfrm>
-            <a:off x="3662487" y="3085039"/>
+            <a:off x="3169176" y="2821633"/>
             <a:ext cx="2651003" cy="1050603"/>
           </a:xfrm>
           <a:prstGeom prst="rect">
@@ -6840,6 +6593,214 @@
           </a:prstGeom>
         </p:spPr>
       </p:pic>
+      <p:sp>
+        <p:nvSpPr>
+          <p:cNvPr id="2" name="Rounded Rectangle 1">
+            <a:extLst>
+              <a:ext uri="{FF2B5EF4-FFF2-40B4-BE49-F238E27FC236}">
+                <a16:creationId xmlns:a16="http://schemas.microsoft.com/office/drawing/2014/main" id="{F0CD52B8-5B2E-7DA6-33F0-31BE865492FD}"/>
+              </a:ext>
+            </a:extLst>
+          </p:cNvPr>
+          <p:cNvSpPr/>
+          <p:nvPr/>
+        </p:nvSpPr>
+        <p:spPr>
+          <a:xfrm>
+            <a:off x="7686212" y="5005603"/>
+            <a:ext cx="212800" cy="212800"/>
+          </a:xfrm>
+          <a:prstGeom prst="roundRect">
+            <a:avLst/>
+          </a:prstGeom>
+          <a:solidFill>
+            <a:schemeClr val="accent5"/>
+          </a:solidFill>
+          <a:ln>
+            <a:noFill/>
+          </a:ln>
+        </p:spPr>
+        <p:style>
+          <a:lnRef idx="2">
+            <a:schemeClr val="accent1">
+              <a:shade val="15000"/>
+            </a:schemeClr>
+          </a:lnRef>
+          <a:fillRef idx="1">
+            <a:schemeClr val="accent1"/>
+          </a:fillRef>
+          <a:effectRef idx="0">
+            <a:schemeClr val="accent1"/>
+          </a:effectRef>
+          <a:fontRef idx="minor">
+            <a:schemeClr val="lt1"/>
+          </a:fontRef>
+        </p:style>
+        <p:txBody>
+          <a:bodyPr rtlCol="0" anchor="ctr"/>
+          <a:lstStyle/>
+          <a:p>
+            <a:pPr algn="ctr"/>
+            <a:endParaRPr lang="en-US"/>
+          </a:p>
+        </p:txBody>
+      </p:sp>
+      <p:sp>
+        <p:nvSpPr>
+          <p:cNvPr id="3" name="Rounded Rectangle 2">
+            <a:extLst>
+              <a:ext uri="{FF2B5EF4-FFF2-40B4-BE49-F238E27FC236}">
+                <a16:creationId xmlns:a16="http://schemas.microsoft.com/office/drawing/2014/main" id="{6EF605EA-72B9-429A-967F-53532894B275}"/>
+              </a:ext>
+            </a:extLst>
+          </p:cNvPr>
+          <p:cNvSpPr/>
+          <p:nvPr/>
+        </p:nvSpPr>
+        <p:spPr>
+          <a:xfrm>
+            <a:off x="7693026" y="5398109"/>
+            <a:ext cx="212800" cy="212800"/>
+          </a:xfrm>
+          <a:prstGeom prst="roundRect">
+            <a:avLst/>
+          </a:prstGeom>
+          <a:solidFill>
+            <a:srgbClr val="FFC819"/>
+          </a:solidFill>
+          <a:ln>
+            <a:noFill/>
+          </a:ln>
+        </p:spPr>
+        <p:style>
+          <a:lnRef idx="2">
+            <a:schemeClr val="accent1">
+              <a:shade val="15000"/>
+            </a:schemeClr>
+          </a:lnRef>
+          <a:fillRef idx="1">
+            <a:schemeClr val="accent1"/>
+          </a:fillRef>
+          <a:effectRef idx="0">
+            <a:schemeClr val="accent1"/>
+          </a:effectRef>
+          <a:fontRef idx="minor">
+            <a:schemeClr val="lt1"/>
+          </a:fontRef>
+        </p:style>
+        <p:txBody>
+          <a:bodyPr rtlCol="0" anchor="ctr"/>
+          <a:lstStyle/>
+          <a:p>
+            <a:pPr algn="ctr"/>
+            <a:endParaRPr lang="en-US"/>
+          </a:p>
+        </p:txBody>
+      </p:sp>
+      <p:sp>
+        <p:nvSpPr>
+          <p:cNvPr id="4" name="Rounded Rectangle 3">
+            <a:extLst>
+              <a:ext uri="{FF2B5EF4-FFF2-40B4-BE49-F238E27FC236}">
+                <a16:creationId xmlns:a16="http://schemas.microsoft.com/office/drawing/2014/main" id="{8F3BF100-E40E-9296-4F1A-60215AA0FD0A}"/>
+              </a:ext>
+            </a:extLst>
+          </p:cNvPr>
+          <p:cNvSpPr/>
+          <p:nvPr/>
+        </p:nvSpPr>
+        <p:spPr>
+          <a:xfrm>
+            <a:off x="7690247" y="5804972"/>
+            <a:ext cx="212800" cy="212800"/>
+          </a:xfrm>
+          <a:prstGeom prst="roundRect">
+            <a:avLst/>
+          </a:prstGeom>
+          <a:solidFill>
+            <a:schemeClr val="accent6"/>
+          </a:solidFill>
+          <a:ln>
+            <a:noFill/>
+          </a:ln>
+        </p:spPr>
+        <p:style>
+          <a:lnRef idx="2">
+            <a:schemeClr val="accent1">
+              <a:shade val="15000"/>
+            </a:schemeClr>
+          </a:lnRef>
+          <a:fillRef idx="1">
+            <a:schemeClr val="accent1"/>
+          </a:fillRef>
+          <a:effectRef idx="0">
+            <a:schemeClr val="accent1"/>
+          </a:effectRef>
+          <a:fontRef idx="minor">
+            <a:schemeClr val="lt1"/>
+          </a:fontRef>
+        </p:style>
+        <p:txBody>
+          <a:bodyPr rtlCol="0" anchor="ctr"/>
+          <a:lstStyle/>
+          <a:p>
+            <a:pPr algn="ctr"/>
+            <a:endParaRPr lang="en-US"/>
+          </a:p>
+        </p:txBody>
+      </p:sp>
+      <p:sp>
+        <p:nvSpPr>
+          <p:cNvPr id="8" name="Rounded Rectangle 7">
+            <a:extLst>
+              <a:ext uri="{FF2B5EF4-FFF2-40B4-BE49-F238E27FC236}">
+                <a16:creationId xmlns:a16="http://schemas.microsoft.com/office/drawing/2014/main" id="{23CDAF6E-8CD8-BAFD-9CB5-813B472F2A9F}"/>
+              </a:ext>
+            </a:extLst>
+          </p:cNvPr>
+          <p:cNvSpPr/>
+          <p:nvPr/>
+        </p:nvSpPr>
+        <p:spPr>
+          <a:xfrm>
+            <a:off x="7686212" y="6211139"/>
+            <a:ext cx="212800" cy="212800"/>
+          </a:xfrm>
+          <a:prstGeom prst="roundRect">
+            <a:avLst/>
+          </a:prstGeom>
+          <a:solidFill>
+            <a:srgbClr val="FF0017"/>
+          </a:solidFill>
+          <a:ln>
+            <a:noFill/>
+          </a:ln>
+        </p:spPr>
+        <p:style>
+          <a:lnRef idx="2">
+            <a:schemeClr val="accent1">
+              <a:shade val="15000"/>
+            </a:schemeClr>
+          </a:lnRef>
+          <a:fillRef idx="1">
+            <a:schemeClr val="accent1"/>
+          </a:fillRef>
+          <a:effectRef idx="0">
+            <a:schemeClr val="accent1"/>
+          </a:effectRef>
+          <a:fontRef idx="minor">
+            <a:schemeClr val="lt1"/>
+          </a:fontRef>
+        </p:style>
+        <p:txBody>
+          <a:bodyPr rtlCol="0" anchor="ctr"/>
+          <a:lstStyle/>
+          <a:p>
+            <a:pPr algn="ctr"/>
+            <a:endParaRPr lang="en-US"/>
+          </a:p>
+        </p:txBody>
+      </p:sp>
     </p:spTree>
     <p:extLst>
       <p:ext uri="{BB962C8B-B14F-4D97-AF65-F5344CB8AC3E}">

</xml_diff>